<commit_message>
feat(review): add themeable cross-format comment UI
Add a built-in read-only comment presentation for DOCX, PPTX, and XLSX while preserving primitive data and geometry APIs for application-owned interfaces. Keep card structure stable and CSS-themeable, remeasure geometry changes independently of optional connectors, and expose comment-aware selection context across formats.

Restore the public documentation boundary: format pages contain live examples, API tables live under /api, and shared ownership, rendering-mode, and optional-renderer guidance lives under /production. Add format comment demos and focused architecture, API, layout, and theme coverage.

Verification: focused comment/API/site tests (269 passed); full site tests (159 passed); Astro static build (31 pages); viewer API symmetry check; git diff --check.

Co-Authored-By: Codex GPT-5 <noreply@openai.com>
</commit_message>
<xml_diff>
--- a/packages/pptx/public/demo/sample-1.pptx
+++ b/packages/pptx/public/demo/sample-1.pptx
@@ -129,6 +129,7 @@
 <file path=ppt/authors.xml><?xml version="1.0" encoding="utf-8"?>
 <p188:authorLst xmlns:a="http://schemas.openxmlformats.org/drawingml/2006/main" xmlns:r="http://schemas.openxmlformats.org/officeDocument/2006/relationships" xmlns:p188="http://schemas.microsoft.com/office/powerpoint/2018/8/main">
   <p188:author id="{9941987A-41B7-49AC-EE6E-03F2D0BD95BA}" name="Daria Naidenov" initials="DN" userId="S::danaidenov@microsoft.com::ab38ab5f-bdf0-4774-ae5a-d2782abb2027" providerId="AD"/>
+  <p188:author id="{55555555-5555-4555-8555-555555555555}" name="Olivia Bennett" initials="OB"/>
 </p188:authorLst>
 </file>
 
@@ -394,6 +395,41 @@
     </a:ln>
   </c:spPr>
 </c:chartSpace>
+</file>
+
+<file path=ppt/comments/modernComment.xml><?xml version="1.0" encoding="utf-8"?>
+<p188:cmLst xmlns:p188="http://schemas.microsoft.com/office/powerpoint/2018/8/main" xmlns:a="http://schemas.openxmlformats.org/drawingml/2006/main" xmlns:pc="http://schemas.microsoft.com/office/powerpoint/2013/main/command" xmlns:ac="http://schemas.microsoft.com/office/drawing/2013/main/command">
+  <p188:cm id="{44444444-4444-4444-8444-444444444444}" authorId="{55555555-5555-4555-8555-555555555555}" status="active" created="2026-08-25T13:00:00Z">
+    <ac:deMkLst>
+      <pc:docMk/>
+      <pc:sldMk sldId="1550"/>
+      <ac:spMk id="3"/>
+    </ac:deMkLst>
+    <p188:pos x="5956300" y="0"/>
+    <p188:replyLst>
+      <p188:reply id="{66666666-6666-4666-8666-666666666666}" authorId="{55555555-5555-4555-8555-555555555555}" status="active" created="2026-08-25T13:01:00Z">
+        <p188:txBody>
+          <a:bodyPr/>
+          <a:lstStyle/>
+          <a:p>
+            <a:r>
+              <a:t>The period matches the source workbook.</a:t>
+            </a:r>
+          </a:p>
+        </p188:txBody>
+      </p188:reply>
+    </p188:replyLst>
+    <p188:txBody>
+      <a:bodyPr/>
+      <a:lstStyle/>
+      <a:p>
+        <a:r>
+          <a:t>Confirm the reporting period before publishing.</a:t>
+        </a:r>
+      </a:p>
+    </p188:txBody>
+  </p188:cm>
+</p188:cmLst>
 </file>
 
 <file path=ppt/handoutMasters/handoutMaster1.xml><?xml version="1.0" encoding="utf-8"?>

</xml_diff>